<commit_message>
Schedule Engine: Area → Building dimension from WBS (Pellet-1/2, Filtration)
- Buildings are taken from the WBS level holding building names (Additive
  Storage Shed, Green Pelletizing Building...), with the level above as the
  new Area / plant dimension; repeated names get the area added.
- Area dropdown, cascading Building dropdown with "Buildings from" level
  selector and area-name option; Area column, groupings, Easy Update,
  Timeline lanes, Setup, Ask and area-wise report tables.
- Demo rebuilt as Pellet Plant-1 / Pellet Plant-2 / Filtration Plant.

Co-Authored-By: Claude Opus 5.5 <noreply@anthropic.com>
Claude-Session: https://claude.ai/code/session_01H1BB9M3EwPpx4pEE5jFoAf
</commit_message>
<xml_diff>
--- a/schedule-engine/samples/Building_Structures_OnePagers.pptx
+++ b/schedule-engine/samples/Building_Structures_OnePagers.pptx
@@ -1613,7 +1613,7 @@
           <a:p>
             <a:r>
               <a:rPr lang="en-US" dirty="0"/>
-              <a:t>TALKING POINTS - SCREEN HOUSE / BUILDING
+              <a:t>TALKING POINTS - SCREEN HOUSE
 1. 1,019 MT scope, vendor Samal Brothers.
 2. 1,019 MT drawings released (100% of scope  ·  nil pending).
 3. Next three months: supply 750 MT, erection 430 MT.
@@ -8498,7 +8498,7 @@
                 <a:ea typeface="Arial" pitchFamily="34" charset="-122"/>
                 <a:cs typeface="Arial" pitchFamily="34" charset="-120"/>
               </a:rPr>
-              <a:t>Screen House / Building</a:t>
+              <a:t>Screen House</a:t>
             </a:r>
             <a:endParaRPr lang="en-US" sz="2600" dirty="0"/>
           </a:p>
@@ -22576,7 +22576,7 @@
                 <a:ea typeface="Arial" pitchFamily="34" charset="-122"/>
                 <a:cs typeface="Arial" pitchFamily="34" charset="-120"/>
               </a:rPr>
-              <a:t>Screen House / Building - supply</a:t>
+              <a:t>Screen House - supply</a:t>
             </a:r>
             <a:endParaRPr lang="en-US" sz="680" dirty="0"/>
           </a:p>
@@ -23061,7 +23061,7 @@
                 <a:ea typeface="Arial" pitchFamily="34" charset="-122"/>
                 <a:cs typeface="Arial" pitchFamily="34" charset="-120"/>
               </a:rPr>
-              <a:t>Screen House / Building - erection</a:t>
+              <a:t>Screen House - erection</a:t>
             </a:r>
             <a:endParaRPr lang="en-US" sz="680" dirty="0"/>
           </a:p>
@@ -25721,7 +25721,7 @@
                 <a:ea typeface="Arial" pitchFamily="34" charset="-122"/>
                 <a:cs typeface="Arial" pitchFamily="34" charset="-120"/>
               </a:rPr>
-              <a:t>Screen House / Building:  Dispatch must jump from 0 MT in Sep-26 to 269 MT/month; Oct and Jan-27 alone need 519 MT.</a:t>
+              <a:t>Screen House:  Dispatch must jump from 0 MT in Sep-26 to 269 MT/month; Oct and Jan-27 alone need 519 MT.</a:t>
             </a:r>
             <a:endParaRPr lang="en-US" sz="720" dirty="0"/>
           </a:p>

</xml_diff>